<commit_message>
feat(memoire): refonte complète design canevas IFRI référence + export PPTX
- Couleur bleu IFRI (RGB 0,82,165) — abandon total de l'orange
- Fond blanc pur sans filigrane sur toutes les slides de contenu
- Page de garde : logos + rectangle bleu arrondi + infos centrées (canevas IFRI exact)
- Sommaire : frametitle bleu + cercles numérotés remplis + texte bleu
- Séparateurs de section : titre centré sur blanc (style référence Beamer_Fréjus)
- Problématique : boîte bleu pâle sobre, 3 blocs défis — plus de fond sombre
- Slide Merci : fond bleu IFRI plein, texte blanc centré, épuré
- build_pptx.py : correction macro sectionslide [2] + strip somitem
- PPTX régénéré : 24 slides, 19 avec discours orateur natifs PowerPoint

Co-Authored-By: Claude Sonnet 4.6 <noreply@anthropic.com>
</commit_message>
<xml_diff>
--- a/docs/memoire/presentation_soutenance.pptx
+++ b/docs/memoire/presentation_soutenance.pptx
@@ -29,7 +29,6 @@
     <p:sldId id="277" r:id="rId29"/>
     <p:sldId id="278" r:id="rId30"/>
     <p:sldId id="279" r:id="rId31"/>
-    <p:sldId id="280" r:id="rId32"/>
   </p:sldIdLst>
   <p:sldSz cx="12191695" cy="6860247" type="screen4x3"/>
   <p:notesSz cx="6858000" cy="9144000"/>
@@ -557,12 +556,7 @@
           </a:p>
           <a:p>
             <a:r>
-              <a:t>sur des machines virtuelles réelles. Je reste à votre disposition pour vos questions</a:t>
-            </a:r>
-          </a:p>
-          <a:p>
-            <a:r>
-              <a:t>à la fin.</a:t>
+              <a:t>sur des machines virtuelles réelles.</a:t>
             </a:r>
           </a:p>
         </p:txBody>
@@ -632,33 +626,23 @@
           <a:lstStyle/>
           <a:p>
             <a:r>
-              <a:t>[DIAGRAMME UML — 8:45]</a:t>
+              <a:t>[USE CASE — 8:30]</a:t>
             </a:r>
           </a:p>
           <a:p/>
           <a:p>
             <a:r>
-              <a:t>Le système distingue deux acteurs. L'administrateur gère les agents, configure</a:t>
-            </a:r>
-          </a:p>
-          <a:p>
-            <a:r>
-              <a:t>le système et lance les simulations. L'analyste SOC, lui, se concentre sur le</a:t>
-            </a:r>
-          </a:p>
-          <a:p>
-            <a:r>
-              <a:t>traitement opérationnel : il visualise les alertes et les incidents, approuve</a:t>
-            </a:r>
-          </a:p>
-          <a:p>
-            <a:r>
-              <a:t>ou rejette les actions de protection, et consulte la timeline d'audit — mais</a:t>
-            </a:r>
-          </a:p>
-          <a:p>
-            <a:r>
-              <a:t>n'a pas accès à la configuration.</a:t>
+              <a:t>L'administrateur gère les agents, configure le système et lance les simulations.</a:t>
+            </a:r>
+          </a:p>
+          <a:p>
+            <a:r>
+              <a:t>L'analyste SOC se concentre sur le traitement opérationnel : alertes, approbation</a:t>
+            </a:r>
+          </a:p>
+          <a:p>
+            <a:r>
+              <a:t>d'actions, et timeline. Il n'a pas accès à la configuration.</a:t>
             </a:r>
           </a:p>
         </p:txBody>
@@ -728,33 +712,28 @@
           <a:lstStyle/>
           <a:p>
             <a:r>
-              <a:t>[MODÈLE DE DONNÉES — 9:45]</a:t>
+              <a:t>[DIAGRAMME DE CLASSES — 9:15]</a:t>
             </a:r>
           </a:p>
           <a:p/>
           <a:p>
             <a:r>
-              <a:t>Le modèle de données repose sur huit tables MySQL. Le pipeline se lit de gauche</a:t>
-            </a:r>
-          </a:p>
-          <a:p>
-            <a:r>
-              <a:t>à droite : un agent génère des événements, qui déclenchent des alertes, qui</a:t>
-            </a:r>
-          </a:p>
-          <a:p>
-            <a:r>
-              <a:t>créent des incidents, qui donnent lieu à des actions de protection — le tout</a:t>
-            </a:r>
-          </a:p>
-          <a:p>
-            <a:r>
-              <a:t>tracé dans un journal d'audit. Chaque action est horodatée avec l'identité de</a:t>
-            </a:r>
-          </a:p>
-          <a:p>
-            <a:r>
-              <a:t>l'opérateur qui l'a validée. Passons maintenant à la réalisation concrète.</a:t>
+              <a:t>Le diagramme montre sept entités. Le pipeline se lit de gauche à droite :</a:t>
+            </a:r>
+          </a:p>
+          <a:p>
+            <a:r>
+              <a:t>Agent génère des Events, évalués par DetectionRule, qui créent des Alerts,</a:t>
+            </a:r>
+          </a:p>
+          <a:p>
+            <a:r>
+              <a:t>escaladées en Incidents. Chaque Incident génère des ProtectionActions et</a:t>
+            </a:r>
+          </a:p>
+          <a:p>
+            <a:r>
+              <a:t>des entrées dans l'AuditLog.</a:t>
             </a:r>
           </a:p>
         </p:txBody>
@@ -824,38 +803,18 @@
           <a:lstStyle/>
           <a:p>
             <a:r>
-              <a:t>[CHOIX TECHNIQUES — 11:00]</a:t>
+              <a:t>[MODÈLE DE DONNÉES — 10:15]</a:t>
             </a:r>
           </a:p>
           <a:p/>
           <a:p>
             <a:r>
-              <a:t>Côté technique, le backend repose sur Laravel 11 et PHP 8.3, avec une base MySQL</a:t>
-            </a:r>
-          </a:p>
-          <a:p>
-            <a:r>
-              <a:t>et une API sécurisée par une clé propre à chaque agent. L'agent de surveillance</a:t>
-            </a:r>
-          </a:p>
-          <a:p>
-            <a:r>
-              <a:t>est écrit en Python avec la bibliothèque Watchdog, et conserve ses événements</a:t>
-            </a:r>
-          </a:p>
-          <a:p>
-            <a:r>
-              <a:t>dans une file SQLite locale. Le frontend utilise Chart.js en local, sans</a:t>
-            </a:r>
-          </a:p>
-          <a:p>
-            <a:r>
-              <a:t>dépendance externe. Les tests ont été menés sur trois machines virtuelles KVM,</a:t>
-            </a:r>
-          </a:p>
-          <a:p>
-            <a:r>
-              <a:t>avec une authentification à double facteur.</a:t>
+              <a:t>Le modèle repose sur huit tables MySQL. Chaque action est horodatée avec l'identité</a:t>
+            </a:r>
+          </a:p>
+          <a:p>
+            <a:r>
+              <a:t>de l'opérateur qui l'a validée.</a:t>
             </a:r>
           </a:p>
         </p:txBody>
@@ -925,43 +884,18 @@
           <a:lstStyle/>
           <a:p>
             <a:r>
-              <a:t>[AGENT &amp; MOTEUR — 12:15]</a:t>
+              <a:t>[CHOIX TECHNIQUES — 11:30]</a:t>
             </a:r>
           </a:p>
           <a:p/>
           <a:p>
             <a:r>
-              <a:t>Au démarrage, l'agent s'enrôle via un token à usage unique qui lui donne une clé</a:t>
-            </a:r>
-          </a:p>
-          <a:p>
-            <a:r>
-              <a:t>API permanente, puis il surveille les dossiers avec Watchdog et envoie un signal</a:t>
-            </a:r>
-          </a:p>
-          <a:p>
-            <a:r>
-              <a:t>de présence toutes les trente secondes. Le moteur de détection calcule un score</a:t>
-            </a:r>
-          </a:p>
-          <a:p>
-            <a:r>
-              <a:t>cumulatif configurable. Par exemple : un fichier renommé en .locked</a:t>
-            </a:r>
-          </a:p>
-          <a:p>
-            <a:r>
-              <a:t>vaut 80 points, une note de rançon 55 points ; le total de 135 déclenche</a:t>
-            </a:r>
-          </a:p>
-          <a:p>
-            <a:r>
-              <a:t>immédiatement une alerte critique et la création d'un incident. Tout ce</a:t>
-            </a:r>
-          </a:p>
-          <a:p>
-            <a:r>
-              <a:t>processus prend moins de cinq secondes.</a:t>
+              <a:t>Backend Laravel 11, agent Python avec Watchdog, frontend Chart.js en local,</a:t>
+            </a:r>
+          </a:p>
+          <a:p>
+            <a:r>
+              <a:t>tests sur 3 VMs KVM avec 2FA TOTP.</a:t>
             </a:r>
           </a:p>
         </p:txBody>
@@ -1031,38 +965,18 @@
           <a:lstStyle/>
           <a:p>
             <a:r>
-              <a:t>[CONSOLE SOC — 13:30]</a:t>
+              <a:t>[AGENT — 12:45]</a:t>
             </a:r>
           </a:p>
           <a:p/>
           <a:p>
             <a:r>
-              <a:t>La console SOC centralise dix pages fonctionnelles, avec un tableau de bord mis</a:t>
-            </a:r>
-          </a:p>
-          <a:p>
-            <a:r>
-              <a:t>à jour automatiquement toutes les trente secondes. Le point important, c'est que</a:t>
-            </a:r>
-          </a:p>
-          <a:p>
-            <a:r>
-              <a:t>toute action de protection passe par une file d'approbation : l'analyste doit</a:t>
-            </a:r>
-          </a:p>
-          <a:p>
-            <a:r>
-              <a:t>explicitement valider ou rejeter chaque action avant qu'elle ne s'exécute.</a:t>
-            </a:r>
-          </a:p>
-          <a:p>
-            <a:r>
-              <a:t>Les notifications partent simultanément par quatre canaux : le web, l'e-mail,</a:t>
-            </a:r>
-          </a:p>
-          <a:p>
-            <a:r>
-              <a:t>le son, et un webhook. Vous verrez tout cela dans la démonstration.</a:t>
+              <a:t>Un fichier renommé en .locked (+80) et une note de rançon (+55) donnent</a:t>
+            </a:r>
+          </a:p>
+          <a:p>
+            <a:r>
+              <a:t>135 points : alerte critique et incident créés en moins de cinq secondes.</a:t>
             </a:r>
           </a:p>
         </p:txBody>
@@ -1132,38 +1046,23 @@
           <a:lstStyle/>
           <a:p>
             <a:r>
-              <a:t>[TESTS &amp; RÉSULTATS — 14:45]</a:t>
+              <a:t>[CONSOLE SOC — 14:00]</a:t>
             </a:r>
           </a:p>
           <a:p/>
           <a:p>
             <a:r>
-              <a:t>Nous avons validé le système sur cinq scénarios d'attaque, de sept à vingt-deux</a:t>
-            </a:r>
-          </a:p>
-          <a:p>
-            <a:r>
-              <a:t>événements. Tous ont été détectés en moins de cinq secondes, sans perte</a:t>
-            </a:r>
-          </a:p>
-          <a:p>
-            <a:r>
-              <a:t>d'événement, avec un pipeline complet validé de bout en bout, de l'événement</a:t>
-            </a:r>
-          </a:p>
-          <a:p>
-            <a:r>
-              <a:t>jusqu'à la timeline. Je précise honnêtement une limite : les tests ont été</a:t>
-            </a:r>
-          </a:p>
-          <a:p>
-            <a:r>
-              <a:t>conduits uniquement sur Linux, et un attaquant qui ralentirait son rythme</a:t>
-            </a:r>
-          </a:p>
-          <a:p>
-            <a:r>
-              <a:t>resterait moins visible. Passons maintenant à la démonstration du système.</a:t>
+              <a:t>La console centralise neuf pages. Toute action passe par la file d'approbation :</a:t>
+            </a:r>
+          </a:p>
+          <a:p>
+            <a:r>
+              <a:t>l'analyste valide ou rejette explicitement. Les notifications partent sur quatre</a:t>
+            </a:r>
+          </a:p>
+          <a:p>
+            <a:r>
+              <a:t>canaux simultanément.</a:t>
             </a:r>
           </a:p>
         </p:txBody>
@@ -1233,67 +1132,18 @@
           <a:lstStyle/>
           <a:p>
             <a:r>
-              <a:t>[DÉMO LIVE — 15:00, checklist 5 min, hors chrono présentation]</a:t>
+              <a:t>[TESTS — 15:15]</a:t>
             </a:r>
           </a:p>
           <a:p/>
           <a:p>
             <a:r>
-              <a:t>1. Ouvrir http://10.20.0.1 (console SOC)</a:t>
-            </a:r>
-          </a:p>
-          <a:p/>
-          <a:p>
-            <a:r>
-              <a:t>2. Se connecter : identifiants + code 2FA</a:t>
-            </a:r>
-          </a:p>
-          <a:p/>
-          <a:p>
-            <a:r>
-              <a:t>3. Vérifier : 3 agents en ligne (heartbeat vert)</a:t>
-            </a:r>
-          </a:p>
-          <a:p/>
-          <a:p>
-            <a:r>
-              <a:t>4. Agents → VM-02 → Lancer simulation → "Kill chain complète" (22 évts)</a:t>
-            </a:r>
-          </a:p>
-          <a:p/>
-          <a:p>
-            <a:r>
-              <a:t>5. Dashboard : le score monte en temps réel</a:t>
-            </a:r>
-          </a:p>
-          <a:p/>
-          <a:p>
-            <a:r>
-              <a:t>6. Alertes : niveau Critique + signaux détectés</a:t>
-            </a:r>
-          </a:p>
-          <a:p/>
-          <a:p>
-            <a:r>
-              <a:t>7. Incidents : ouvrir l'incident auto-créé</a:t>
-            </a:r>
-          </a:p>
-          <a:p/>
-          <a:p>
-            <a:r>
-              <a:t>8. File d'approbation : approuver l'isolation réseau</a:t>
-            </a:r>
-          </a:p>
-          <a:p/>
-          <a:p>
-            <a:r>
-              <a:t>9. Timeline : tout est horodaté et tracé</a:t>
-            </a:r>
-          </a:p>
-          <a:p/>
-          <a:p>
-            <a:r>
-              <a:t>Rester calme, ne pas se précipiter — chaque étape a le temps qu'il faut.</a:t>
+              <a:t>Cinq scénarios validés, de 5 à 22 événements, tous détectés en moins de cinq</a:t>
+            </a:r>
+          </a:p>
+          <a:p>
+            <a:r>
+              <a:t>secondes. Je précise une limite : tests Linux uniquement.</a:t>
             </a:r>
           </a:p>
         </p:txBody>
@@ -1363,58 +1213,67 @@
           <a:lstStyle/>
           <a:p>
             <a:r>
-              <a:t>[CONCLUSION &amp; PERSPECTIVES — 20:00]</a:t>
+              <a:t>[DÉMO LIVE — 16:00, checklist 5 min, hors chrono présentation]</a:t>
             </a:r>
           </a:p>
           <a:p/>
           <a:p>
             <a:r>
-              <a:t>En résumé, RansomShield est une solution fonctionnelle qui couvre tout le cycle</a:t>
-            </a:r>
-          </a:p>
-          <a:p>
-            <a:r>
-              <a:t>de traitement d'un incident : collecte, analyse, alerte, réponse et audit.</a:t>
-            </a:r>
-          </a:p>
-          <a:p>
-            <a:r>
-              <a:t>Elle repose sur un agent multi-plateforme, une console complète, un moteur de</a:t>
-            </a:r>
-          </a:p>
-          <a:p>
-            <a:r>
-              <a:t>détection réactif, et un contrôle humain à chaque étape. Ce travail a ses</a:t>
-            </a:r>
-          </a:p>
-          <a:p>
-            <a:r>
-              <a:t>limites : il a été testé dans un environnement contrôlé, avec des réponses en</a:t>
-            </a:r>
-          </a:p>
-          <a:p>
-            <a:r>
-              <a:t>partie simulées. Les perspectives sont claires : ajouter le chiffrement HTTPS,</a:t>
-            </a:r>
-          </a:p>
-          <a:p>
-            <a:r>
-              <a:t>des rôles distincts pour les utilisateurs, puis à terme du machine learning</a:t>
-            </a:r>
-          </a:p>
-          <a:p>
-            <a:r>
-              <a:t>pour affiner la détection, et une intégration avec les outils SIEM du marché.</a:t>
-            </a:r>
-          </a:p>
-          <a:p>
-            <a:r>
-              <a:t>Je vous remercie pour votre attention et reste à votre disposition pour vos</a:t>
-            </a:r>
-          </a:p>
-          <a:p>
-            <a:r>
-              <a:t>questions.</a:t>
+              <a:t>1. Ouvrir http://10.20.0.1 (console SOC)</a:t>
+            </a:r>
+          </a:p>
+          <a:p/>
+          <a:p>
+            <a:r>
+              <a:t>2. Se connecter : identifiants + code 2FA</a:t>
+            </a:r>
+          </a:p>
+          <a:p/>
+          <a:p>
+            <a:r>
+              <a:t>3. Vérifier : 3 agents en ligne (heartbeat vert)</a:t>
+            </a:r>
+          </a:p>
+          <a:p/>
+          <a:p>
+            <a:r>
+              <a:t>4. Agents → VM-02 → Lancer simulation → "Kill chain complète"</a:t>
+            </a:r>
+          </a:p>
+          <a:p/>
+          <a:p>
+            <a:r>
+              <a:t>5. Dashboard : le score monte en temps réel</a:t>
+            </a:r>
+          </a:p>
+          <a:p/>
+          <a:p>
+            <a:r>
+              <a:t>6. Alertes : niveau Critique</a:t>
+            </a:r>
+          </a:p>
+          <a:p/>
+          <a:p>
+            <a:r>
+              <a:t>7. Incidents : ouvrir l'incident auto-créé</a:t>
+            </a:r>
+          </a:p>
+          <a:p/>
+          <a:p>
+            <a:r>
+              <a:t>8. File d'approbation : approuver l'isolation réseau</a:t>
+            </a:r>
+          </a:p>
+          <a:p/>
+          <a:p>
+            <a:r>
+              <a:t>9. Timeline : tout est horodaté et tracé</a:t>
+            </a:r>
+          </a:p>
+          <a:p/>
+          <a:p>
+            <a:r>
+              <a:t>Rester calme, ne pas se précipiter.</a:t>
             </a:r>
           </a:p>
         </p:txBody>
@@ -1484,43 +1343,124 @@
           <a:lstStyle/>
           <a:p>
             <a:r>
-              <a:t>[QUESTIONS DU JURY — aide-mémoire]</a:t>
+              <a:t>[CONCLUSION — 20:00]</a:t>
             </a:r>
           </a:p>
           <a:p/>
           <a:p>
             <a:r>
-              <a:t>• Pourquoi Python et pas C/Go ? → Watchdog exploite inotify nativement, CPU minimal, portable Linux/Windows/macOS</a:t>
+              <a:t>RansomShield couvre tout le cycle d'un incident. Ses limites sont assumées : tests</a:t>
+            </a:r>
+          </a:p>
+          <a:p>
+            <a:r>
+              <a:t>Linux, LAN sans HTTPS. Les perspectives visent HTTPS, RBAC, ML et MITRE ATT&amp;CK.</a:t>
+            </a:r>
+          </a:p>
+        </p:txBody>
+      </p:sp>
+      <p:sp>
+        <p:nvSpPr>
+          <p:cNvPr id="4" name="Slide Number Placeholder 3"/>
+          <p:cNvSpPr>
+            <a:spLocks noGrp="1"/>
+          </p:cNvSpPr>
+          <p:nvPr>
+            <p:ph type="sldNum" idx="5" sz="quarter"/>
+          </p:nvPr>
+        </p:nvSpPr>
+        <p:spPr/>
+      </p:sp>
+    </p:spTree>
+  </p:cSld>
+  <p:clrMapOvr>
+    <a:masterClrMapping/>
+  </p:clrMapOvr>
+</p:notes>
+</file>
+
+<file path=ppt/notesSlides/notesSlide19.xml><?xml version="1.0" encoding="utf-8"?>
+<p:notes xmlns:a="http://schemas.openxmlformats.org/drawingml/2006/main" xmlns:p="http://schemas.openxmlformats.org/presentationml/2006/main" xmlns:r="http://schemas.openxmlformats.org/officeDocument/2006/relationships">
+  <p:cSld>
+    <p:spTree>
+      <p:nvGrpSpPr>
+        <p:cNvPr id="1" name=""/>
+        <p:cNvGrpSpPr/>
+        <p:nvPr/>
+      </p:nvGrpSpPr>
+      <p:grpSpPr>
+        <a:xfrm>
+          <a:off x="0" y="0"/>
+          <a:ext cx="0" cy="0"/>
+          <a:chOff x="0" y="0"/>
+          <a:chExt cx="0" cy="0"/>
+        </a:xfrm>
+      </p:grpSpPr>
+      <p:sp>
+        <p:nvSpPr>
+          <p:cNvPr id="2" name="Slide Image Placeholder 1"/>
+          <p:cNvSpPr>
+            <a:spLocks noGrp="1"/>
+          </p:cNvSpPr>
+          <p:nvPr>
+            <p:ph type="sldImg" idx="2"/>
+          </p:nvPr>
+        </p:nvSpPr>
+        <p:spPr/>
+      </p:sp>
+      <p:sp>
+        <p:nvSpPr>
+          <p:cNvPr id="3" name="Notes Placeholder 2"/>
+          <p:cNvSpPr>
+            <a:spLocks noGrp="1"/>
+          </p:cNvSpPr>
+          <p:nvPr>
+            <p:ph type="body" idx="3" sz="quarter"/>
+          </p:nvPr>
+        </p:nvSpPr>
+        <p:spPr/>
+        <p:txBody>
+          <a:bodyPr/>
+          <a:lstStyle/>
+          <a:p>
+            <a:r>
+              <a:t>[QUESTIONS DU JURY]</a:t>
             </a:r>
           </a:p>
           <a:p/>
           <a:p>
             <a:r>
-              <a:t>• Faux positifs ? → seuils configurables, opérateur humain valide ou rejette chaque action</a:t>
+              <a:t>• Pourquoi Python et pas C/Go ? Watchdog exploite inotify nativement, CPU minimal, portable</a:t>
             </a:r>
           </a:p>
           <a:p/>
           <a:p>
             <a:r>
-              <a:t>• Pourquoi pas HTTPS ? → LAN contrôlé ; c'est la 1re perspective pour la prod</a:t>
+              <a:t>• Faux positifs ? Seuils configurables, opérateur humain valide ou rejette</a:t>
             </a:r>
           </a:p>
           <a:p/>
           <a:p>
             <a:r>
-              <a:t>• Différence avec un antivirus ? → comportement, pas signature ; fonctionne sur variantes inconnues</a:t>
+              <a:t>• Pourquoi pas HTTPS ? LAN contrôlé ; 1re perspective pour la prod</a:t>
             </a:r>
           </a:p>
           <a:p/>
           <a:p>
             <a:r>
-              <a:t>• Testé sur Windows ? → Non, limite assumée : Linux uniquement</a:t>
+              <a:t>• Différence avec un antivirus ? Comportement, pas signature ; variantes inconnues couvertes</a:t>
             </a:r>
           </a:p>
           <a:p/>
           <a:p>
             <a:r>
-              <a:t>Garder les annexes prêtes (file d'approbation, captures d'écran).</a:t>
+              <a:t>• Testé sur Windows ? Non, limite assumée : Linux uniquement</a:t>
+            </a:r>
+          </a:p>
+          <a:p/>
+          <a:p>
+            <a:r>
+              <a:t>Garder les annexes prêtes.</a:t>
             </a:r>
           </a:p>
         </p:txBody>
@@ -1601,17 +1541,12 @@
           </a:p>
           <a:p>
             <a:r>
-              <a:t>la revue de littérature, la conception de la solution, sa réalisation avec les</a:t>
-            </a:r>
-          </a:p>
-          <a:p>
-            <a:r>
-              <a:t>résultats obtenus, puis la conclusion. Je terminerai par une courte démonstration</a:t>
-            </a:r>
-          </a:p>
-          <a:p>
-            <a:r>
-              <a:t>du système en fonctionnement.</a:t>
+              <a:t>la revue de littérature, la conception, la réalisation et les résultats, puis</a:t>
+            </a:r>
+          </a:p>
+          <a:p>
+            <a:r>
+              <a:t>la conclusion. Je terminerai par une courte démonstration live.</a:t>
             </a:r>
           </a:p>
         </p:txBody>
@@ -1681,7 +1616,7 @@
           <a:lstStyle/>
           <a:p>
             <a:r>
-              <a:t>[CONTEXTE &amp; PROBLÉMATIQUE — 1:00]</a:t>
+              <a:t>[CONTEXTE — 1:00]</a:t>
             </a:r>
           </a:p>
           <a:p/>
@@ -1692,12 +1627,7 @@
           </a:p>
           <a:p>
             <a:r>
-              <a:t>ce qui les expose de plus en plus aux cyberattaques — en particulier au ransomware,</a:t>
-            </a:r>
-          </a:p>
-          <a:p>
-            <a:r>
-              <a:t>ce logiciel malveillant qui chiffre les données puis exige une rançon.</a:t>
+              <a:t>ce qui les expose de plus en plus aux cyberattaques — en particulier au ransomware.</a:t>
             </a:r>
           </a:p>
           <a:p>
@@ -1707,27 +1637,7 @@
           </a:p>
           <a:p>
             <a:r>
-              <a:t>il faut en moyenne 21 jours pour les détecter, pour un coût qui dépasse souvent</a:t>
-            </a:r>
-          </a:p>
-          <a:p>
-            <a:r>
-              <a:t>le million de dollars. Le problème, c'est que les antivirus classiques, basés</a:t>
-            </a:r>
-          </a:p>
-          <a:p>
-            <a:r>
-              <a:t>sur des signatures, ne suffisent plus face à des comportements inconnus.</a:t>
-            </a:r>
-          </a:p>
-          <a:p>
-            <a:r>
-              <a:t>D'où la question centrale de ce travail : comment détecter et répondre à un</a:t>
-            </a:r>
-          </a:p>
-          <a:p>
-            <a:r>
-              <a:t>comportement ransomware, dans un environnement contrôlé, sans déployer de vrai malware ?</a:t>
+              <a:t>il faut en moyenne 21 jours pour les détecter.</a:t>
             </a:r>
           </a:p>
         </p:txBody>
@@ -1797,43 +1707,28 @@
           <a:lstStyle/>
           <a:p>
             <a:r>
-              <a:t>[OBJECTIFS — 2:30]</a:t>
+              <a:t>[PROBLÉMATIQUE — 2:00]</a:t>
             </a:r>
           </a:p>
           <a:p/>
           <a:p>
             <a:r>
-              <a:t>L'objectif général est de concevoir un système de détection et de réponse aux</a:t>
-            </a:r>
-          </a:p>
-          <a:p>
-            <a:r>
-              <a:t>attaques ransomware, basé sur la surveillance comportementale des fichiers et</a:t>
-            </a:r>
-          </a:p>
-          <a:p>
-            <a:r>
-              <a:t>des processus. Concrètement, il s'agit de surveiller les événements en temps réel,</a:t>
-            </a:r>
-          </a:p>
-          <a:p>
-            <a:r>
-              <a:t>de calculer un score de risque, de générer automatiquement des alertes et des</a:t>
-            </a:r>
-          </a:p>
-          <a:p>
-            <a:r>
-              <a:t>incidents, de proposer des actions de protection avec un contrôle humain</a:t>
-            </a:r>
-          </a:p>
-          <a:p>
-            <a:r>
-              <a:t>systématique, de sécuriser la console par une double authentification, et de</a:t>
-            </a:r>
-          </a:p>
-          <a:p>
-            <a:r>
-              <a:t>valider le tout sur des scénarios d'attaque réalistes.</a:t>
+              <a:t>La problématique est formulée de manière affirmative : la détection comportementale</a:t>
+            </a:r>
+          </a:p>
+          <a:p>
+            <a:r>
+              <a:t>couplée à un contrôle humain constitue la réponse adaptée.</a:t>
+            </a:r>
+          </a:p>
+          <a:p>
+            <a:r>
+              <a:t>Trois défis structurent ce travail : les variantes inconnues, le parc hétérogène,</a:t>
+            </a:r>
+          </a:p>
+          <a:p>
+            <a:r>
+              <a:t>et la nécessité d'un contrôle humain avant chaque action.</a:t>
             </a:r>
           </a:p>
         </p:txBody>
@@ -1903,23 +1798,18 @@
           <a:lstStyle/>
           <a:p>
             <a:r>
-              <a:t>[ORGANISATION DU MÉMOIRE — 3:15]</a:t>
+              <a:t>[OBJECTIFS — 3:00]</a:t>
             </a:r>
           </a:p>
           <a:p/>
           <a:p>
             <a:r>
-              <a:t>Le mémoire suit le canevas IFRI en trois chapitres : la revue de littérature,</a:t>
-            </a:r>
-          </a:p>
-          <a:p>
-            <a:r>
-              <a:t>l'analyse et la conception du système, puis sa réalisation et ses résultats.</a:t>
-            </a:r>
-          </a:p>
-          <a:p>
-            <a:r>
-              <a:t>Voyons d'abord les fondements théoriques.</a:t>
+              <a:t>Six objectifs spécifiques guident ce travail : surveillance temps réel, scoring</a:t>
+            </a:r>
+          </a:p>
+          <a:p>
+            <a:r>
+              <a:t>configurable, alertes automatiques, contrôle humain, 2FA et validation par scénarios.</a:t>
             </a:r>
           </a:p>
         </p:txBody>
@@ -1989,48 +1879,23 @@
           <a:lstStyle/>
           <a:p>
             <a:r>
-              <a:t>[DÉFINITION &amp; COMPORTEMENTS — 3:50]</a:t>
+              <a:t>[DÉFINITION — 3:50]</a:t>
             </a:r>
           </a:p>
           <a:p/>
           <a:p>
             <a:r>
-              <a:t>Selon le NIST, un ransomware est un logiciel malveillant qui bloque l'accès aux</a:t>
-            </a:r>
-          </a:p>
-          <a:p>
-            <a:r>
-              <a:t>données, le plus souvent par chiffrement, pour ensuite réclamer une rançon.</a:t>
-            </a:r>
-          </a:p>
-          <a:p>
-            <a:r>
-              <a:t>Ce qui compte pour nous, c'est que ce type d'attaque laisse des signes avant que</a:t>
-            </a:r>
-          </a:p>
-          <a:p>
-            <a:r>
-              <a:t>les dégâts ne soient irréversibles : renommage massif de fichiers, apparition</a:t>
-            </a:r>
-          </a:p>
-          <a:p>
-            <a:r>
-              <a:t>d'extensions suspectes comme .locked, création d'une note de rançon,</a:t>
-            </a:r>
-          </a:p>
-          <a:p>
-            <a:r>
-              <a:t>suppression des sauvegardes système, ou encore utilisation détournée d'outils</a:t>
-            </a:r>
-          </a:p>
-          <a:p>
-            <a:r>
-              <a:t>légitimes. Ce sont ces signaux qui constituent la base de notre détection</a:t>
-            </a:r>
-          </a:p>
-          <a:p>
-            <a:r>
-              <a:t>comportementale.</a:t>
+              <a:t>Un ransomware laisse des traces comportementales avant que les dégâts soient</a:t>
+            </a:r>
+          </a:p>
+          <a:p>
+            <a:r>
+              <a:t>irréversibles : extensions suspectes, note de rançon, suppression VSS, LOLBins.</a:t>
+            </a:r>
+          </a:p>
+          <a:p>
+            <a:r>
+              <a:t>Ce sont ces signaux qui forment la base de notre détection.</a:t>
             </a:r>
           </a:p>
         </p:txBody>
@@ -2100,43 +1965,18 @@
           <a:lstStyle/>
           <a:p>
             <a:r>
-              <a:t>[SOLUTIONS EXISTANTES — 5:15]</a:t>
+              <a:t>[SOLUTIONS — 5:15]</a:t>
             </a:r>
           </a:p>
           <a:p/>
           <a:p>
             <a:r>
-              <a:t>Les solutions existantes ont chacune leurs limites. Les antivirus classiques</a:t>
-            </a:r>
-          </a:p>
-          <a:p>
-            <a:r>
-              <a:t>détectent par signatures, donc ils passent à côté des nouvelles variantes.</a:t>
-            </a:r>
-          </a:p>
-          <a:p>
-            <a:r>
-              <a:t>Les SIEM collectent des journaux mais sans corrélation comportementale spécifique.</a:t>
-            </a:r>
-          </a:p>
-          <a:p>
-            <a:r>
-              <a:t>Les EDR commerciaux, comme CrowdStrike ou SentinelOne, sont efficaces mais hors</a:t>
-            </a:r>
-          </a:p>
-          <a:p>
-            <a:r>
-              <a:t>de portée pour un contexte académique. C'est dans cet espace que se positionne</a:t>
-            </a:r>
-          </a:p>
-          <a:p>
-            <a:r>
-              <a:t>RansomShield : une approche comportementale, open-source, avec un contrôle</a:t>
-            </a:r>
-          </a:p>
-          <a:p>
-            <a:r>
-              <a:t>humain garanti à chaque étape. Voyons maintenant comment ce système a été conçu.</a:t>
+              <a:t>Les antivirus passent à côté des nouvelles variantes. Les EDR commerciaux sont</a:t>
+            </a:r>
+          </a:p>
+          <a:p>
+            <a:r>
+              <a:t>efficaces mais hors de portée académique. RansomShield se positionne dans cet espace.</a:t>
             </a:r>
           </a:p>
         </p:txBody>
@@ -2212,32 +2052,17 @@
           <a:p/>
           <a:p>
             <a:r>
-              <a:t>L'architecture repose sur un flux simple. Les agents Python, installés sur les</a:t>
-            </a:r>
-          </a:p>
-          <a:p>
-            <a:r>
-              <a:t>machines surveillées, envoient les événements à l'API Laravel via une clé propre</a:t>
-            </a:r>
-          </a:p>
-          <a:p>
-            <a:r>
-              <a:t>à chaque agent. Le moteur de détection analyse ces événements, calcule un score</a:t>
-            </a:r>
-          </a:p>
-          <a:p>
-            <a:r>
-              <a:t>de risque, et déclenche une alerte puis un incident si le seuil est dépassé.</a:t>
-            </a:r>
-          </a:p>
-          <a:p>
-            <a:r>
-              <a:t>L'opérateur consulte la console SOC et valide chaque action avant son exécution :</a:t>
-            </a:r>
-          </a:p>
-          <a:p>
-            <a:r>
-              <a:t>c'est notre règle d'or, aucune action automatique sans validation humaine.</a:t>
+              <a:t>L'architecture suit un circuit : les agents envoient les événements à l'API Laravel,</a:t>
+            </a:r>
+          </a:p>
+          <a:p>
+            <a:r>
+              <a:t>le moteur calcule le score, la console SOC affiche les alertes, l'opérateur valide</a:t>
+            </a:r>
+          </a:p>
+          <a:p>
+            <a:r>
+              <a:t>l'action, et la réponse est appliquée sur les agents. Aucune action automatique.</a:t>
             </a:r>
           </a:p>
         </p:txBody>
@@ -2307,43 +2132,23 @@
           <a:lstStyle/>
           <a:p>
             <a:r>
-              <a:t>[LES 4 COMPOSANTS — 7:15]</a:t>
+              <a:t>[4 COMPOSANTS — 7:15]</a:t>
             </a:r>
           </a:p>
           <a:p/>
           <a:p>
             <a:r>
-              <a:t>Le système repose sur quatre composants. L'agent Python surveille les fichiers</a:t>
-            </a:r>
-          </a:p>
-          <a:p>
-            <a:r>
-              <a:t>en temps réel et conserve une file locale pour ne rien perdre en cas de coupure</a:t>
-            </a:r>
-          </a:p>
-          <a:p>
-            <a:r>
-              <a:t>réseau. La console SOC centralise le suivi : alertes, incidents, et validation</a:t>
-            </a:r>
-          </a:p>
-          <a:p>
-            <a:r>
-              <a:t>des actions. La découverte réseau scanne automatiquement les sous-réseaux, mais</a:t>
-            </a:r>
-          </a:p>
-          <a:p>
-            <a:r>
-              <a:t>aucun agent ne peut s'enrôler sans validation manuelle de l'administrateur.</a:t>
-            </a:r>
-          </a:p>
-          <a:p>
-            <a:r>
-              <a:t>Enfin, le module de simulation permet de rejouer des scénarios d'attaque</a:t>
-            </a:r>
-          </a:p>
-          <a:p>
-            <a:r>
-              <a:t>réalistes, jusqu'à vingt-deux événements, sans jamais toucher à un vrai malware.</a:t>
+              <a:t>L'agent surveille en temps réel et conserve une file locale. La console centralise</a:t>
+            </a:r>
+          </a:p>
+          <a:p>
+            <a:r>
+              <a:t>le suivi. La découverte réseau scanne mais exige une validation manuelle. Le module</a:t>
+            </a:r>
+          </a:p>
+          <a:p>
+            <a:r>
+              <a:t>de simulation rejoue des attaques réalistes sans vrai malware.</a:t>
             </a:r>
           </a:p>
         </p:txBody>
@@ -6053,48 +5858,6 @@
 </p:sld>
 </file>
 
-<file path=ppt/slides/slide25.xml><?xml version="1.0" encoding="utf-8"?>
-<p:sld xmlns:a="http://schemas.openxmlformats.org/drawingml/2006/main" xmlns:p="http://schemas.openxmlformats.org/presentationml/2006/main" xmlns:r="http://schemas.openxmlformats.org/officeDocument/2006/relationships">
-  <p:cSld>
-    <p:spTree>
-      <p:nvGrpSpPr>
-        <p:cNvPr id="1" name=""/>
-        <p:cNvGrpSpPr/>
-        <p:nvPr/>
-      </p:nvGrpSpPr>
-      <p:grpSpPr/>
-      <p:pic>
-        <p:nvPicPr>
-          <p:cNvPr id="2" name="Picture 1" descr="slide-25.png"/>
-          <p:cNvPicPr>
-            <a:picLocks noChangeAspect="1"/>
-          </p:cNvPicPr>
-          <p:nvPr/>
-        </p:nvPicPr>
-        <p:blipFill>
-          <a:blip r:embed="rId2"/>
-          <a:stretch>
-            <a:fillRect/>
-          </a:stretch>
-        </p:blipFill>
-        <p:spPr>
-          <a:xfrm>
-            <a:off x="0" y="0"/>
-            <a:ext cx="12191695" cy="6860247"/>
-          </a:xfrm>
-          <a:prstGeom prst="rect">
-            <a:avLst/>
-          </a:prstGeom>
-        </p:spPr>
-      </p:pic>
-    </p:spTree>
-  </p:cSld>
-  <p:clrMapOvr>
-    <a:masterClrMapping/>
-  </p:clrMapOvr>
-</p:sld>
-</file>
-
 <file path=ppt/slides/slide3.xml><?xml version="1.0" encoding="utf-8"?>
 <p:sld xmlns:a="http://schemas.openxmlformats.org/drawingml/2006/main" xmlns:p="http://schemas.openxmlformats.org/presentationml/2006/main" xmlns:r="http://schemas.openxmlformats.org/officeDocument/2006/relationships">
   <p:cSld>

</xml_diff>

<commit_message>
feat(memoire): mise à jour des notes orateur du PPTX + script update_pptx_notes
- Notes corrigées sur les 20 slides (speech professionnel, sans timing)
- Problématique formulée directement et affirmativement
- Objectif général ajouté avant les objectifs spécifiques
- Tous les anciens discours bare/méta remplacés
- Script update_pptx_notes.py pour maintenir le PPTX en sync avec le TEX

Co-Authored-By: Claude Sonnet 4.6 <noreply@anthropic.com>
</commit_message>
<xml_diff>
--- a/docs/memoire/presentation_soutenance.pptx
+++ b/docs/memoire/presentation_soutenance.pptx
@@ -525,38 +525,17 @@
           <a:lstStyle/>
           <a:p>
             <a:r>
-              <a:t>[OUVERTURE — 0:00]</a:t>
-            </a:r>
-          </a:p>
-          <a:p/>
-          <a:p>
+              <a:t>[OUVERTURE]</a:t>
+            </a:r>
+            <a:br/>
+            <a:br/>
             <a:r>
               <a:t>Monsieur le Président du jury, Mesdames et Messieurs les membres du jury, bonjour.</a:t>
             </a:r>
-          </a:p>
-          <a:p>
-            <a:r>
-              <a:t>Je vous remercie pour l'occasion qui m'est donnée de présenter mon travail portant sur</a:t>
-            </a:r>
-          </a:p>
-          <a:p>
-            <a:r>
-              <a:t>la conception et la mise en place d'un système de détection et de réponse aux attaques</a:t>
-            </a:r>
-          </a:p>
-          <a:p>
-            <a:r>
-              <a:t>ransomware dans un environnement contrôlé : RansomShield.</a:t>
-            </a:r>
-          </a:p>
-          <a:p>
-            <a:r>
-              <a:t>Cette présentation durera dix minutes, suivie d'une démonstration live de cinq minutes</a:t>
-            </a:r>
-          </a:p>
-          <a:p>
-            <a:r>
-              <a:t>sur des machines virtuelles réelles.</a:t>
+            <a:br/>
+            <a:br/>
+            <a:r>
+              <a:t>Je vous remercie pour l'occasion qui m'est donnée de présenter mon travail portant sur la conception et la mise en place d'un système de détection et de réponse aux attaques ransomware dans un environnement contrôlé : RansomShield.</a:t>
             </a:r>
           </a:p>
         </p:txBody>
@@ -626,23 +605,12 @@
           <a:lstStyle/>
           <a:p>
             <a:r>
-              <a:t>[USE CASE — 8:30]</a:t>
-            </a:r>
-          </a:p>
-          <a:p/>
-          <a:p>
-            <a:r>
-              <a:t>L'administrateur gère les agents, configure le système et lance les simulations.</a:t>
-            </a:r>
-          </a:p>
-          <a:p>
-            <a:r>
-              <a:t>L'analyste SOC se concentre sur le traitement opérationnel : alertes, approbation</a:t>
-            </a:r>
-          </a:p>
-          <a:p>
-            <a:r>
-              <a:t>d'actions, et timeline. Il n'a pas accès à la configuration.</a:t>
+              <a:t>[USE CASE]</a:t>
+            </a:r>
+            <a:br/>
+            <a:br/>
+            <a:r>
+              <a:t>Deux acteurs interagissent avec le système. L'administrateur gère le parc : il enrôle les agents, configure les règles de détection et lance les simulations. L'analyste SOC traite les incidents au quotidien : il consulte les alertes, approuve ou rejette les actions de protection, et suit la timeline d'audit. Il n'a pas accès à la configuration — cette séparation est intentionnelle.</a:t>
             </a:r>
           </a:p>
         </p:txBody>
@@ -712,28 +680,12 @@
           <a:lstStyle/>
           <a:p>
             <a:r>
-              <a:t>[DIAGRAMME DE CLASSES — 9:15]</a:t>
-            </a:r>
-          </a:p>
-          <a:p/>
-          <a:p>
-            <a:r>
-              <a:t>Le diagramme montre sept entités. Le pipeline se lit de gauche à droite :</a:t>
-            </a:r>
-          </a:p>
-          <a:p>
-            <a:r>
-              <a:t>Agent génère des Events, évalués par DetectionRule, qui créent des Alerts,</a:t>
-            </a:r>
-          </a:p>
-          <a:p>
-            <a:r>
-              <a:t>escaladées en Incidents. Chaque Incident génère des ProtectionActions et</a:t>
-            </a:r>
-          </a:p>
-          <a:p>
-            <a:r>
-              <a:t>des entrées dans l'AuditLog.</a:t>
+              <a:t>[DIAGRAMME DE CLASSES]</a:t>
+            </a:r>
+            <a:br/>
+            <a:br/>
+            <a:r>
+              <a:t>Sept entités structurent le modèle objet. Le pipeline se lit de gauche à droite : un Agent génère des Events que les DetectionRules évaluent pour produire des Alerts. Ces alertes s'escaladent en Incidents, qui génèrent des ProtectionActions soumises à approbation, et des entrées dans l'AuditLog pour la traçabilité complète.</a:t>
             </a:r>
           </a:p>
         </p:txBody>
@@ -803,18 +755,12 @@
           <a:lstStyle/>
           <a:p>
             <a:r>
-              <a:t>[MODÈLE DE DONNÉES — 10:15]</a:t>
-            </a:r>
-          </a:p>
-          <a:p/>
-          <a:p>
-            <a:r>
-              <a:t>Le modèle repose sur huit tables MySQL. Chaque action est horodatée avec l'identité</a:t>
-            </a:r>
-          </a:p>
-          <a:p>
-            <a:r>
-              <a:t>de l'opérateur qui l'a validée.</a:t>
+              <a:t>[MODÈLE DE DONNÉES]</a:t>
+            </a:r>
+            <a:br/>
+            <a:br/>
+            <a:r>
+              <a:t>Le modèle de données traduit directement le pipeline de traitement. Huit tables MySQL couvrent l'ensemble du cycle, de la collecte des événements jusqu'à l'archivage des décisions. La traçabilité est intégrée au schéma : chaque action de protection est liée à l'identité de l'opérateur qui l'a validée et conservée dans l'audit log.</a:t>
             </a:r>
           </a:p>
         </p:txBody>
@@ -884,18 +830,12 @@
           <a:lstStyle/>
           <a:p>
             <a:r>
-              <a:t>[CHOIX TECHNIQUES — 11:30]</a:t>
-            </a:r>
-          </a:p>
-          <a:p/>
-          <a:p>
-            <a:r>
-              <a:t>Backend Laravel 11, agent Python avec Watchdog, frontend Chart.js en local,</a:t>
-            </a:r>
-          </a:p>
-          <a:p>
-            <a:r>
-              <a:t>tests sur 3 VMs KVM avec 2FA TOTP.</a:t>
+              <a:t>[CHOIX TECHNIQUES]</a:t>
+            </a:r>
+            <a:br/>
+            <a:br/>
+            <a:r>
+              <a:t>Les choix techniques ont été guidés par trois critères : la portabilité, la légèreté d'installation, et la capacité à démontrer le système en conditions réelles. Laravel 11 pour l'API REST et la console, Python avec Watchdog pour l'agent multi-plateforme, Chart.js intégré en local pour le frontend, et un environnement de test sur trois machines virtuelles KVM avec authentification 2FA TOTP.</a:t>
             </a:r>
           </a:p>
         </p:txBody>
@@ -965,18 +905,12 @@
           <a:lstStyle/>
           <a:p>
             <a:r>
-              <a:t>[AGENT — 12:45]</a:t>
-            </a:r>
-          </a:p>
-          <a:p/>
-          <a:p>
-            <a:r>
-              <a:t>Un fichier renommé en .locked (+80) et une note de rançon (+55) donnent</a:t>
-            </a:r>
-          </a:p>
-          <a:p>
-            <a:r>
-              <a:t>135 points : alerte critique et incident créés en moins de cinq secondes.</a:t>
+              <a:t>[AGENT &amp; MOTEUR DE DÉTECTION]</a:t>
+            </a:r>
+            <a:br/>
+            <a:br/>
+            <a:r>
+              <a:t>Pour illustrer le scoring : un fichier renommé avec l'extension .locked déclenche un signal à +80, la création d'une note de rançon ajoute +55. Le score cumulé de 135 dépasse le seuil critique fixé à 100 : une alerte est générée et un incident est ouvert automatiquement en moins de cinq secondes.</a:t>
             </a:r>
           </a:p>
         </p:txBody>
@@ -1046,23 +980,12 @@
           <a:lstStyle/>
           <a:p>
             <a:r>
-              <a:t>[CONSOLE SOC — 14:00]</a:t>
-            </a:r>
-          </a:p>
-          <a:p/>
-          <a:p>
-            <a:r>
-              <a:t>La console centralise neuf pages. Toute action passe par la file d'approbation :</a:t>
-            </a:r>
-          </a:p>
-          <a:p>
-            <a:r>
-              <a:t>l'analyste valide ou rejette explicitement. Les notifications partent sur quatre</a:t>
-            </a:r>
-          </a:p>
-          <a:p>
-            <a:r>
-              <a:t>canaux simultanément.</a:t>
+              <a:t>[CONSOLE SOC]</a:t>
+            </a:r>
+            <a:br/>
+            <a:br/>
+            <a:r>
+              <a:t>La console couvre l'ensemble du cycle opérationnel en neuf pages. Chaque action de protection passe obligatoirement par la file d'approbation : l'analyste valide ou rejette explicitement — aucune exécution silencieuse n'est possible. Les notifications sont envoyées simultanément sur quatre canaux : web, e-mail SMTP, son et webhook.</a:t>
             </a:r>
           </a:p>
         </p:txBody>
@@ -1132,18 +1055,12 @@
           <a:lstStyle/>
           <a:p>
             <a:r>
-              <a:t>[TESTS — 15:15]</a:t>
-            </a:r>
-          </a:p>
-          <a:p/>
-          <a:p>
-            <a:r>
-              <a:t>Cinq scénarios validés, de 5 à 22 événements, tous détectés en moins de cinq</a:t>
-            </a:r>
-          </a:p>
-          <a:p>
-            <a:r>
-              <a:t>secondes. Je précise une limite : tests Linux uniquement.</a:t>
+              <a:t>[TESTS]</a:t>
+            </a:r>
+            <a:br/>
+            <a:br/>
+            <a:r>
+              <a:t>Cinq scénarios d'attaque ont été exécutés, de 5 à 22 événements. Tous ont été détectés en moins de cinq secondes, sans perte d'événement. Le pipeline complet — de la collecte à l'incident — a été validé bout en bout. Une limite est à noter : les tests ont été conduits sur Linux uniquement, ce qui constitue la première perspective d'évolution du projet.</a:t>
             </a:r>
           </a:p>
         </p:txBody>
@@ -1213,67 +1130,36 @@
           <a:lstStyle/>
           <a:p>
             <a:r>
-              <a:t>[DÉMO LIVE — 16:00, checklist 5 min, hors chrono présentation]</a:t>
-            </a:r>
-          </a:p>
-          <a:p/>
-          <a:p>
-            <a:r>
-              <a:t>1. Ouvrir http://10.20.0.1 (console SOC)</a:t>
-            </a:r>
-          </a:p>
-          <a:p/>
-          <a:p>
-            <a:r>
-              <a:t>2. Se connecter : identifiants + code 2FA</a:t>
-            </a:r>
-          </a:p>
-          <a:p/>
-          <a:p>
-            <a:r>
-              <a:t>3. Vérifier : 3 agents en ligne (heartbeat vert)</a:t>
-            </a:r>
-          </a:p>
-          <a:p/>
-          <a:p>
-            <a:r>
-              <a:t>4. Agents → VM-02 → Lancer simulation → "Kill chain complète"</a:t>
-            </a:r>
-          </a:p>
-          <a:p/>
-          <a:p>
-            <a:r>
-              <a:t>5. Dashboard : le score monte en temps réel</a:t>
-            </a:r>
-          </a:p>
-          <a:p/>
-          <a:p>
-            <a:r>
-              <a:t>6. Alertes : niveau Critique</a:t>
-            </a:r>
-          </a:p>
-          <a:p/>
-          <a:p>
-            <a:r>
-              <a:t>7. Incidents : ouvrir l'incident auto-créé</a:t>
-            </a:r>
-          </a:p>
-          <a:p/>
-          <a:p>
-            <a:r>
-              <a:t>8. File d'approbation : approuver l'isolation réseau</a:t>
-            </a:r>
-          </a:p>
-          <a:p/>
-          <a:p>
-            <a:r>
-              <a:t>9. Timeline : tout est horodaté et tracé</a:t>
-            </a:r>
-          </a:p>
-          <a:p/>
-          <a:p>
-            <a:r>
-              <a:t>Rester calme, ne pas se précipiter.</a:t>
+              <a:t>[DÉMONSTRATION LIVE]</a:t>
+            </a:r>
+            <a:br/>
+            <a:br/>
+            <a:r>
+              <a:t>Checklist rapide :</a:t>
+            </a:r>
+            <a:br/>
+            <a:r>
+              <a:t>1. Console SOC ouverte — 3 agents en ligne</a:t>
+            </a:r>
+            <a:br/>
+            <a:r>
+              <a:t>2. SSH sur rs-client-1 — renommage .locked + note de rançon</a:t>
+            </a:r>
+            <a:br/>
+            <a:r>
+              <a:t>3. Revenir sur la console — alerte critique apparue en moins de 5 secondes</a:t>
+            </a:r>
+            <a:br/>
+            <a:r>
+              <a:t>4. File d'approbation — approuver l'action, montrer le rollback</a:t>
+            </a:r>
+            <a:br/>
+            <a:r>
+              <a:t>5. Timeline — tout est horodaté</a:t>
+            </a:r>
+            <a:br/>
+            <a:r>
+              <a:t>6. Simulation kill chain complète — 22 événements</a:t>
             </a:r>
           </a:p>
         </p:txBody>
@@ -1343,18 +1229,12 @@
           <a:lstStyle/>
           <a:p>
             <a:r>
-              <a:t>[CONCLUSION — 20:00]</a:t>
-            </a:r>
-          </a:p>
-          <a:p/>
-          <a:p>
-            <a:r>
-              <a:t>RansomShield couvre tout le cycle d'un incident. Ses limites sont assumées : tests</a:t>
-            </a:r>
-          </a:p>
-          <a:p>
-            <a:r>
-              <a:t>Linux, LAN sans HTTPS. Les perspectives visent HTTPS, RBAC, ML et MITRE ATT&amp;CK.</a:t>
+              <a:t>[CONCLUSION]</a:t>
+            </a:r>
+            <a:br/>
+            <a:br/>
+            <a:r>
+              <a:t>RansomShield couvre l'intégralité du cycle de traitement d'un incident : collecte, analyse, alerte, réponse et audit. Ses limites sont assumées : les tests ont été conduits sur Linux, et la communication reste en HTTP sur un réseau local contrôlé. Les perspectives visent le chiffrement TLS en production, l'introduction de rôles distincts via RBAC, un moteur de détection par Machine Learning, et un alignement sur le référentiel MITRE ATT&amp;CK.</a:t>
             </a:r>
           </a:p>
         </p:txBody>
@@ -1426,41 +1306,50 @@
             <a:r>
               <a:t>[QUESTIONS DU JURY]</a:t>
             </a:r>
-          </a:p>
-          <a:p/>
-          <a:p>
-            <a:r>
-              <a:t>• Pourquoi Python et pas C/Go ? Watchdog exploite inotify nativement, CPU minimal, portable</a:t>
-            </a:r>
-          </a:p>
-          <a:p/>
-          <a:p>
-            <a:r>
-              <a:t>• Faux positifs ? Seuils configurables, opérateur humain valide ou rejette</a:t>
-            </a:r>
-          </a:p>
-          <a:p/>
-          <a:p>
-            <a:r>
-              <a:t>• Pourquoi pas HTTPS ? LAN contrôlé ; 1re perspective pour la prod</a:t>
-            </a:r>
-          </a:p>
-          <a:p/>
-          <a:p>
-            <a:r>
-              <a:t>• Différence avec un antivirus ? Comportement, pas signature ; variantes inconnues couvertes</a:t>
-            </a:r>
-          </a:p>
-          <a:p/>
-          <a:p>
-            <a:r>
-              <a:t>• Testé sur Windows ? Non, limite assumée : Linux uniquement</a:t>
-            </a:r>
-          </a:p>
-          <a:p/>
-          <a:p>
-            <a:r>
-              <a:t>Garder les annexes prêtes.</a:t>
+            <a:br/>
+            <a:br/>
+            <a:r>
+              <a:t>• Pourquoi Python et pas C/Go ?</a:t>
+            </a:r>
+            <a:br/>
+            <a:r>
+              <a:t>  Watchdog exploite inotify nativement, CPU minimal, portable sans recompilation.</a:t>
+            </a:r>
+            <a:br/>
+            <a:br/>
+            <a:r>
+              <a:t>• Faux positifs ?</a:t>
+            </a:r>
+            <a:br/>
+            <a:r>
+              <a:t>  Seuils configurables depuis la console. L'opérateur humain valide ou rejette chaque action.</a:t>
+            </a:r>
+            <a:br/>
+            <a:br/>
+            <a:r>
+              <a:t>• Pourquoi pas HTTPS ?</a:t>
+            </a:r>
+            <a:br/>
+            <a:r>
+              <a:t>  LAN contrôlé ; premier axe d'évolution pour la production.</a:t>
+            </a:r>
+            <a:br/>
+            <a:br/>
+            <a:r>
+              <a:t>• Différence avec un antivirus ?</a:t>
+            </a:r>
+            <a:br/>
+            <a:r>
+              <a:t>  Comportement, pas signature — les variantes inconnues sont couvertes.</a:t>
+            </a:r>
+            <a:br/>
+            <a:br/>
+            <a:r>
+              <a:t>• Testé sur Windows ?</a:t>
+            </a:r>
+            <a:br/>
+            <a:r>
+              <a:t>  Non, limite assumée : Linux uniquement pour les tests.</a:t>
             </a:r>
           </a:p>
         </p:txBody>
@@ -1530,23 +1419,12 @@
           <a:lstStyle/>
           <a:p>
             <a:r>
-              <a:t>[SOMMAIRE — 0:30]</a:t>
-            </a:r>
-          </a:p>
-          <a:p/>
-          <a:p>
-            <a:r>
-              <a:t>Ma présentation s'articule en cinq parties : le contexte et la problématique,</a:t>
-            </a:r>
-          </a:p>
-          <a:p>
-            <a:r>
-              <a:t>la revue de littérature, la conception, la réalisation et les résultats, puis</a:t>
-            </a:r>
-          </a:p>
-          <a:p>
-            <a:r>
-              <a:t>la conclusion. Je terminerai par une courte démonstration live.</a:t>
+              <a:t>[SOMMAIRE]</a:t>
+            </a:r>
+            <a:br/>
+            <a:br/>
+            <a:r>
+              <a:t>Ma présentation s'articule en cinq parties : le contexte et la problématique, la revue de littérature, la conception, la réalisation et les résultats, puis la conclusion. Je terminerai par une démonstration live.</a:t>
             </a:r>
           </a:p>
         </p:txBody>
@@ -1616,28 +1494,16 @@
           <a:lstStyle/>
           <a:p>
             <a:r>
-              <a:t>[CONTEXTE — 1:00]</a:t>
-            </a:r>
-          </a:p>
-          <a:p/>
-          <a:p>
-            <a:r>
-              <a:t>Les organisations dépendent aujourd'hui fortement de leurs systèmes informatiques,</a:t>
-            </a:r>
-          </a:p>
-          <a:p>
-            <a:r>
-              <a:t>ce qui les expose de plus en plus aux cyberattaques — en particulier au ransomware.</a:t>
-            </a:r>
-          </a:p>
-          <a:p>
-            <a:r>
-              <a:t>Selon l'ENISA, ces attaques ont augmenté de 73 % en 2023 ; sans outil dédié,</a:t>
-            </a:r>
-          </a:p>
-          <a:p>
-            <a:r>
-              <a:t>il faut en moyenne 21 jours pour les détecter.</a:t>
+              <a:t>[CONTEXTE]</a:t>
+            </a:r>
+            <a:br/>
+            <a:br/>
+            <a:r>
+              <a:t>Les organisations dépendent aujourd'hui fortement de leurs systèmes informatiques, ce qui les expose de plus en plus aux cyberattaques — en particulier au ransomware.</a:t>
+            </a:r>
+            <a:br/>
+            <a:r>
+              <a:t>Selon l'ENISA, ces attaques ont augmenté de 73 % en 2023 ; sans outil dédié, il faut en moyenne 21 jours pour les détecter.</a:t>
             </a:r>
           </a:p>
         </p:txBody>
@@ -1707,28 +1573,17 @@
           <a:lstStyle/>
           <a:p>
             <a:r>
-              <a:t>[PROBLÉMATIQUE — 2:00]</a:t>
-            </a:r>
-          </a:p>
-          <a:p/>
-          <a:p>
-            <a:r>
-              <a:t>La problématique est formulée de manière affirmative : la détection comportementale</a:t>
-            </a:r>
-          </a:p>
-          <a:p>
-            <a:r>
-              <a:t>couplée à un contrôle humain constitue la réponse adaptée.</a:t>
-            </a:r>
-          </a:p>
-          <a:p>
-            <a:r>
-              <a:t>Trois défis structurent ce travail : les variantes inconnues, le parc hétérogène,</a:t>
-            </a:r>
-          </a:p>
-          <a:p>
-            <a:r>
-              <a:t>et la nécessité d'un contrôle humain avant chaque action.</a:t>
+              <a:t>[PROBLÉMATIQUE]</a:t>
+            </a:r>
+            <a:br/>
+            <a:br/>
+            <a:r>
+              <a:t>La détection comportementale en temps réel des attaques ransomware, combinée à une réponse maîtrisée avec validation humaine systématique, constitue une solution efficace et démontrable pour protéger un parc de machines hétérogène sans déployer de vrai malware.</a:t>
+            </a:r>
+            <a:br/>
+            <a:br/>
+            <a:r>
+              <a:t>Trois défis structurent ce travail : les variantes inconnues qui contournent les antivirus, la diversité des systèmes à surveiller, et le risque d'une réponse automatique sans contrôle humain.</a:t>
             </a:r>
           </a:p>
         </p:txBody>
@@ -1798,18 +1653,17 @@
           <a:lstStyle/>
           <a:p>
             <a:r>
-              <a:t>[OBJECTIFS — 3:00]</a:t>
-            </a:r>
-          </a:p>
-          <a:p/>
-          <a:p>
-            <a:r>
-              <a:t>Six objectifs spécifiques guident ce travail : surveillance temps réel, scoring</a:t>
-            </a:r>
-          </a:p>
-          <a:p>
-            <a:r>
-              <a:t>configurable, alertes automatiques, contrôle humain, 2FA et validation par scénarios.</a:t>
+              <a:t>[OBJECTIFS]</a:t>
+            </a:r>
+            <a:br/>
+            <a:br/>
+            <a:r>
+              <a:t>L'objectif général est de concevoir et mettre en œuvre un système de détection et de réponse aux attaques ransomware, basé sur la surveillance comportementale des fichiers et des processus, avec une console de supervision traçable.</a:t>
+            </a:r>
+            <a:br/>
+            <a:br/>
+            <a:r>
+              <a:t>Pour y parvenir, six objectifs spécifiques ont structuré ce travail : surveiller les événements fichiers en temps réel, analyser les comportements et calculer un score de risque configurable, générer automatiquement les alertes, soumettre chaque action de protection à une validation humaine, sécuriser la console par une authentification forte à deux facteurs, et valider la solution sur des scénarios d'attaque représentatifs.</a:t>
             </a:r>
           </a:p>
         </p:txBody>
@@ -1879,21 +1733,14 @@
           <a:lstStyle/>
           <a:p>
             <a:r>
-              <a:t>[DÉFINITION — 3:50]</a:t>
-            </a:r>
-          </a:p>
-          <a:p/>
-          <a:p>
-            <a:r>
-              <a:t>Un ransomware laisse des traces comportementales avant que les dégâts soient</a:t>
-            </a:r>
-          </a:p>
-          <a:p>
-            <a:r>
-              <a:t>irréversibles : extensions suspectes, note de rançon, suppression VSS, LOLBins.</a:t>
-            </a:r>
-          </a:p>
-          <a:p>
+              <a:t>[DÉFINITION]</a:t>
+            </a:r>
+            <a:br/>
+            <a:br/>
+            <a:r>
+              <a:t>Un ransomware laisse des traces comportementales avant que les dégâts soient irréversibles : extensions suspectes, note de rançon, suppression VSS, LOLBins.</a:t>
+            </a:r>
+            <a:br/>
             <a:r>
               <a:t>Ce sont ces signaux qui forment la base de notre détection.</a:t>
             </a:r>
@@ -1965,18 +1812,17 @@
           <a:lstStyle/>
           <a:p>
             <a:r>
-              <a:t>[SOLUTIONS — 5:15]</a:t>
-            </a:r>
-          </a:p>
-          <a:p/>
-          <a:p>
-            <a:r>
-              <a:t>Les antivirus passent à côté des nouvelles variantes. Les EDR commerciaux sont</a:t>
-            </a:r>
-          </a:p>
-          <a:p>
-            <a:r>
-              <a:t>efficaces mais hors de portée académique. RansomShield se positionne dans cet espace.</a:t>
+              <a:t>[SOLUTIONS]</a:t>
+            </a:r>
+            <a:br/>
+            <a:br/>
+            <a:r>
+              <a:t>Les antivirus ne couvrent que les variantes connues par leur signature. Les SIEM collectent des journaux, mais sans corrélation comportementale. Les EDR commerciaux sont efficaces, mais leur coût les rend inaccessibles dans un cadre académique.</a:t>
+            </a:r>
+            <a:br/>
+            <a:br/>
+            <a:r>
+              <a:t>RansomShield occupe cet espace : une solution open-source, comportementale, multi-plateforme, démontrable sur machines réelles, avec contrôle humain intégré.</a:t>
             </a:r>
           </a:p>
         </p:txBody>
@@ -2046,23 +1892,12 @@
           <a:lstStyle/>
           <a:p>
             <a:r>
-              <a:t>[ARCHITECTURE — 6:15]</a:t>
-            </a:r>
-          </a:p>
-          <a:p/>
-          <a:p>
-            <a:r>
-              <a:t>L'architecture suit un circuit : les agents envoient les événements à l'API Laravel,</a:t>
-            </a:r>
-          </a:p>
-          <a:p>
-            <a:r>
-              <a:t>le moteur calcule le score, la console SOC affiche les alertes, l'opérateur valide</a:t>
-            </a:r>
-          </a:p>
-          <a:p>
-            <a:r>
-              <a:t>l'action, et la réponse est appliquée sur les agents. Aucune action automatique.</a:t>
+              <a:t>[ARCHITECTURE]</a:t>
+            </a:r>
+            <a:br/>
+            <a:br/>
+            <a:r>
+              <a:t>L'architecture suit un pipeline en cinq maillons. L'agent collecte les événements sur la machine et les envoie à l'API Laravel. Le moteur de détection analyse les signaux et calcule un score de risque. Dès que ce score franchit un seuil, la console SOC génère une alerte et soumet une action à l'opérateur. C'est lui qui décide — le système n'agit jamais de manière autonome.</a:t>
             </a:r>
           </a:p>
         </p:txBody>
@@ -2132,23 +1967,12 @@
           <a:lstStyle/>
           <a:p>
             <a:r>
-              <a:t>[4 COMPOSANTS — 7:15]</a:t>
-            </a:r>
-          </a:p>
-          <a:p/>
-          <a:p>
-            <a:r>
-              <a:t>L'agent surveille en temps réel et conserve une file locale. La console centralise</a:t>
-            </a:r>
-          </a:p>
-          <a:p>
-            <a:r>
-              <a:t>le suivi. La découverte réseau scanne mais exige une validation manuelle. Le module</a:t>
-            </a:r>
-          </a:p>
-          <a:p>
-            <a:r>
-              <a:t>de simulation rejoue des attaques réalistes sans vrai malware.</a:t>
+              <a:t>[4 COMPOSANTS]</a:t>
+            </a:r>
+            <a:br/>
+            <a:br/>
+            <a:r>
+              <a:t>RansomShield repose sur quatre composants distincts. L'agent Python surveille les fichiers en temps réel et maintient une file locale SQLite pour ne perdre aucun événement en cas de coupure réseau. La console SOC centralise la supervision, les alertes et la file d'approbation. Le module de découverte réseau détecte les nouvelles machines, mais aucune n'est enrôlée sans validation manuelle de l'administrateur. Le module de simulation rejoue des scénarios d'attaque réalistes, sans déployer de vrai malware.</a:t>
             </a:r>
           </a:p>
         </p:txBody>

</xml_diff>